<commit_message>
Laya + MCTS benefits slide: add three conclusions
Co-Authored-By: Claude Opus 5.5 <noreply@anthropic.com>
Claude-Session: https://claude.ai/code/session_01RobwG4fG7s83Eyb7XAeMFj
</commit_message>
<xml_diff>
--- a/docs/laya_mcts_benefits.pptx
+++ b/docs/laya_mcts_benefits.pptx
@@ -507,7 +507,7 @@
 結合後，Laya 告訴搜尋該往哪裡試、局面看起來有沒有希望；搜尋則往前驗證，修正 Laya 一時的誤判。
 在最難的關卡，成功率從不用 Laya 的 13% 提高到 89%，成功時平均 8.6 步，接近最少的 8 步。
 另外三個好處：只會選合法動作、每一步有成功機率可以當信心分數、能在模擬環境中自我練習（比只學示範的 59% 高到 89%）。
-前提是 Laya 要先在這類任務上訓練過。</a:t>
+三個結論：Laya + MCTS 顯著優於只用 MCTS；Laya 一定要先針對任務微調，未微調時加上搜尋反而比 MCTS 差（7% 對 13%）；這套方法每走一步要試走 16 次，速度測試中近八成時間花在遊戲模擬，所以需要快速、低成本的模擬環境。</a:t>
             </a:r>
             <a:endParaRPr lang="en-US" dirty="0"/>
           </a:p>
@@ -1027,12 +1027,12 @@
         </p:nvSpPr>
         <p:spPr>
           <a:xfrm>
-            <a:off x="685800" y="1691640"/>
-            <a:ext cx="3154680" cy="2423160"/>
+            <a:off x="685800" y="1600200"/>
+            <a:ext cx="3154680" cy="2103120"/>
           </a:xfrm>
           <a:prstGeom prst="roundRect">
             <a:avLst>
-              <a:gd name="adj" fmla="val 3774"/>
+              <a:gd name="adj" fmla="val 4348"/>
             </a:avLst>
           </a:prstGeom>
           <a:solidFill>
@@ -1054,7 +1054,7 @@
         </p:nvSpPr>
         <p:spPr>
           <a:xfrm>
-            <a:off x="914400" y="1892808"/>
+            <a:off x="914400" y="1801368"/>
             <a:ext cx="2697480" cy="411480"/>
           </a:xfrm>
           <a:prstGeom prst="rect">
@@ -1090,7 +1090,7 @@
         </p:nvSpPr>
         <p:spPr>
           <a:xfrm>
-            <a:off x="914400" y="2350008"/>
+            <a:off x="914400" y="2258568"/>
             <a:ext cx="2697480" cy="566928"/>
           </a:xfrm>
           <a:prstGeom prst="rect">
@@ -1126,7 +1126,7 @@
         </p:nvSpPr>
         <p:spPr>
           <a:xfrm>
-            <a:off x="914400" y="3108960"/>
+            <a:off x="914400" y="2880360"/>
             <a:ext cx="2697480" cy="0"/>
           </a:xfrm>
           <a:prstGeom prst="line">
@@ -1149,8 +1149,8 @@
         </p:nvSpPr>
         <p:spPr>
           <a:xfrm>
-            <a:off x="914400" y="3246120"/>
-            <a:ext cx="2697480" cy="731520"/>
+            <a:off x="914400" y="2971800"/>
+            <a:ext cx="2697480" cy="658368"/>
           </a:xfrm>
           <a:prstGeom prst="rect">
             <a:avLst/>
@@ -1164,7 +1164,7 @@
           <a:p>
             <a:pPr indent="0" marL="0">
               <a:spcAft>
-                <a:spcPts val="300"/>
+                <a:spcPts val="200"/>
               </a:spcAft>
               <a:buNone/>
             </a:pPr>
@@ -1181,7 +1181,7 @@
           <a:p>
             <a:pPr indent="0" marL="0">
               <a:spcAft>
-                <a:spcPts val="300"/>
+                <a:spcPts val="200"/>
               </a:spcAft>
               <a:buNone/>
             </a:pPr>
@@ -1205,7 +1205,7 @@
         </p:nvSpPr>
         <p:spPr>
           <a:xfrm>
-            <a:off x="3840480" y="2583180"/>
+            <a:off x="3840480" y="2331720"/>
             <a:ext cx="566928" cy="640080"/>
           </a:xfrm>
           <a:prstGeom prst="rect">
@@ -1241,12 +1241,12 @@
         </p:nvSpPr>
         <p:spPr>
           <a:xfrm>
-            <a:off x="4407408" y="1691640"/>
-            <a:ext cx="3154680" cy="2423160"/>
+            <a:off x="4407408" y="1600200"/>
+            <a:ext cx="3154680" cy="2103120"/>
           </a:xfrm>
           <a:prstGeom prst="roundRect">
             <a:avLst>
-              <a:gd name="adj" fmla="val 3774"/>
+              <a:gd name="adj" fmla="val 4348"/>
             </a:avLst>
           </a:prstGeom>
           <a:solidFill>
@@ -1268,7 +1268,7 @@
         </p:nvSpPr>
         <p:spPr>
           <a:xfrm>
-            <a:off x="4636008" y="1892808"/>
+            <a:off x="4636008" y="1801368"/>
             <a:ext cx="2697480" cy="411480"/>
           </a:xfrm>
           <a:prstGeom prst="rect">
@@ -1304,7 +1304,7 @@
         </p:nvSpPr>
         <p:spPr>
           <a:xfrm>
-            <a:off x="4636008" y="2350008"/>
+            <a:off x="4636008" y="2258568"/>
             <a:ext cx="2697480" cy="566928"/>
           </a:xfrm>
           <a:prstGeom prst="rect">
@@ -1340,7 +1340,7 @@
         </p:nvSpPr>
         <p:spPr>
           <a:xfrm>
-            <a:off x="4636008" y="3108960"/>
+            <a:off x="4636008" y="2880360"/>
             <a:ext cx="2697480" cy="0"/>
           </a:xfrm>
           <a:prstGeom prst="line">
@@ -1363,8 +1363,8 @@
         </p:nvSpPr>
         <p:spPr>
           <a:xfrm>
-            <a:off x="4636008" y="3246120"/>
-            <a:ext cx="2697480" cy="731520"/>
+            <a:off x="4636008" y="2971800"/>
+            <a:ext cx="2697480" cy="658368"/>
           </a:xfrm>
           <a:prstGeom prst="rect">
             <a:avLst/>
@@ -1378,7 +1378,7 @@
           <a:p>
             <a:pPr indent="0" marL="0">
               <a:spcAft>
-                <a:spcPts val="300"/>
+                <a:spcPts val="200"/>
               </a:spcAft>
               <a:buNone/>
             </a:pPr>
@@ -1395,7 +1395,7 @@
           <a:p>
             <a:pPr indent="0" marL="0">
               <a:spcAft>
-                <a:spcPts val="300"/>
+                <a:spcPts val="200"/>
               </a:spcAft>
               <a:buNone/>
             </a:pPr>
@@ -1419,7 +1419,7 @@
         </p:nvSpPr>
         <p:spPr>
           <a:xfrm>
-            <a:off x="7562088" y="2583180"/>
+            <a:off x="7562088" y="2331720"/>
             <a:ext cx="566928" cy="640080"/>
           </a:xfrm>
           <a:prstGeom prst="rect">
@@ -1455,12 +1455,12 @@
         </p:nvSpPr>
         <p:spPr>
           <a:xfrm>
-            <a:off x="8129016" y="1691640"/>
-            <a:ext cx="3376879" cy="2423160"/>
+            <a:off x="8129016" y="1600200"/>
+            <a:ext cx="3376879" cy="2103120"/>
           </a:xfrm>
           <a:prstGeom prst="roundRect">
             <a:avLst>
-              <a:gd name="adj" fmla="val 3774"/>
+              <a:gd name="adj" fmla="val 4348"/>
             </a:avLst>
           </a:prstGeom>
           <a:solidFill>
@@ -1482,7 +1482,7 @@
         </p:nvSpPr>
         <p:spPr>
           <a:xfrm>
-            <a:off x="8357616" y="1892808"/>
+            <a:off x="8357616" y="1801368"/>
             <a:ext cx="2919679" cy="411480"/>
           </a:xfrm>
           <a:prstGeom prst="rect">
@@ -1518,7 +1518,7 @@
         </p:nvSpPr>
         <p:spPr>
           <a:xfrm>
-            <a:off x="8357616" y="2350008"/>
+            <a:off x="8357616" y="2258568"/>
             <a:ext cx="2919679" cy="566928"/>
           </a:xfrm>
           <a:prstGeom prst="rect">
@@ -1554,8 +1554,8 @@
         </p:nvSpPr>
         <p:spPr>
           <a:xfrm>
-            <a:off x="8357616" y="3063240"/>
-            <a:ext cx="2919679" cy="914400"/>
+            <a:off x="8357616" y="2743200"/>
+            <a:ext cx="2919679" cy="868680"/>
           </a:xfrm>
           <a:prstGeom prst="rect">
             <a:avLst/>
@@ -1571,7 +1571,7 @@
               <a:buNone/>
             </a:pPr>
             <a:r>
-              <a:rPr lang="en-US" sz="3600" b="1" dirty="0">
+              <a:rPr lang="en-US" sz="3200" b="1" dirty="0">
                 <a:solidFill>
                   <a:schemeClr val="accent1"/>
                 </a:solidFill>
@@ -1618,7 +1618,7 @@
         </p:nvSpPr>
         <p:spPr>
           <a:xfrm>
-            <a:off x="685800" y="4297680"/>
+            <a:off x="685800" y="3941064"/>
             <a:ext cx="3657600" cy="274320"/>
           </a:xfrm>
           <a:prstGeom prst="rect">
@@ -1654,12 +1654,12 @@
         </p:nvSpPr>
         <p:spPr>
           <a:xfrm>
-            <a:off x="685800" y="4663440"/>
-            <a:ext cx="2533574" cy="1325880"/>
+            <a:off x="685800" y="4224528"/>
+            <a:ext cx="2533574" cy="1024128"/>
           </a:xfrm>
           <a:prstGeom prst="roundRect">
             <a:avLst>
-              <a:gd name="adj" fmla="val 5517"/>
+              <a:gd name="adj" fmla="val 7143"/>
             </a:avLst>
           </a:prstGeom>
           <a:solidFill>
@@ -1681,7 +1681,7 @@
         </p:nvSpPr>
         <p:spPr>
           <a:xfrm>
-            <a:off x="886968" y="4882896"/>
+            <a:off x="886968" y="4352544"/>
             <a:ext cx="310896" cy="310896"/>
           </a:xfrm>
           <a:prstGeom prst="ellipse">
@@ -1706,7 +1706,7 @@
         </p:nvSpPr>
         <p:spPr>
           <a:xfrm>
-            <a:off x="886968" y="4882896"/>
+            <a:off x="886968" y="4352544"/>
             <a:ext cx="310896" cy="310896"/>
           </a:xfrm>
           <a:prstGeom prst="rect">
@@ -1742,8 +1742,8 @@
         </p:nvSpPr>
         <p:spPr>
           <a:xfrm>
-            <a:off x="1307592" y="4864608"/>
-            <a:ext cx="1756334" cy="365760"/>
+            <a:off x="1307592" y="4334256"/>
+            <a:ext cx="1756334" cy="347472"/>
           </a:xfrm>
           <a:prstGeom prst="rect">
             <a:avLst/>
@@ -1759,14 +1759,14 @@
               <a:buNone/>
             </a:pPr>
             <a:r>
-              <a:rPr lang="en-US" sz="1600" b="1" dirty="0">
+              <a:rPr lang="en-US" sz="1500" b="1" dirty="0">
                 <a:solidFill>
                   <a:schemeClr val="tx1"/>
                 </a:solidFill>
               </a:rPr>
               <a:t>更準、更有效率</a:t>
             </a:r>
-            <a:endParaRPr lang="en-US" sz="1600" dirty="0"/>
+            <a:endParaRPr lang="en-US" sz="1500" dirty="0"/>
           </a:p>
         </p:txBody>
       </p:sp>
@@ -1778,8 +1778,8 @@
         </p:nvSpPr>
         <p:spPr>
           <a:xfrm>
-            <a:off x="886968" y="5321808"/>
-            <a:ext cx="2131238" cy="685800"/>
+            <a:off x="886968" y="4736592"/>
+            <a:ext cx="2131238" cy="457200"/>
           </a:xfrm>
           <a:prstGeom prst="rect">
             <a:avLst/>
@@ -1795,14 +1795,14 @@
               <a:buNone/>
             </a:pPr>
             <a:r>
-              <a:rPr lang="en-US" sz="1250" dirty="0">
+              <a:rPr lang="en-US" sz="1200" dirty="0">
                 <a:solidFill>
                   <a:schemeClr val="tx1"/>
                 </a:solidFill>
               </a:rPr>
               <a:t>成功的場次平均 8.6 步，接近任務最少的 8 步</a:t>
             </a:r>
-            <a:endParaRPr lang="en-US" sz="1250" dirty="0"/>
+            <a:endParaRPr lang="en-US" sz="1200" dirty="0"/>
           </a:p>
         </p:txBody>
       </p:sp>
@@ -1814,12 +1814,12 @@
         </p:nvSpPr>
         <p:spPr>
           <a:xfrm>
-            <a:off x="3447974" y="4663440"/>
-            <a:ext cx="2533574" cy="1325880"/>
+            <a:off x="3447974" y="4224528"/>
+            <a:ext cx="2533574" cy="1024128"/>
           </a:xfrm>
           <a:prstGeom prst="roundRect">
             <a:avLst>
-              <a:gd name="adj" fmla="val 5517"/>
+              <a:gd name="adj" fmla="val 7143"/>
             </a:avLst>
           </a:prstGeom>
           <a:solidFill>
@@ -1841,7 +1841,7 @@
         </p:nvSpPr>
         <p:spPr>
           <a:xfrm>
-            <a:off x="3649142" y="4882896"/>
+            <a:off x="3649142" y="4352544"/>
             <a:ext cx="310896" cy="310896"/>
           </a:xfrm>
           <a:prstGeom prst="ellipse">
@@ -1866,7 +1866,7 @@
         </p:nvSpPr>
         <p:spPr>
           <a:xfrm>
-            <a:off x="3649142" y="4882896"/>
+            <a:off x="3649142" y="4352544"/>
             <a:ext cx="310896" cy="310896"/>
           </a:xfrm>
           <a:prstGeom prst="rect">
@@ -1902,8 +1902,8 @@
         </p:nvSpPr>
         <p:spPr>
           <a:xfrm>
-            <a:off x="4069766" y="4864608"/>
-            <a:ext cx="1756334" cy="365760"/>
+            <a:off x="4069766" y="4334256"/>
+            <a:ext cx="1756334" cy="347472"/>
           </a:xfrm>
           <a:prstGeom prst="rect">
             <a:avLst/>
@@ -1919,14 +1919,14 @@
               <a:buNone/>
             </a:pPr>
             <a:r>
-              <a:rPr lang="en-US" sz="1600" b="1" dirty="0">
+              <a:rPr lang="en-US" sz="1500" b="1" dirty="0">
                 <a:solidFill>
                   <a:schemeClr val="tx1"/>
                 </a:solidFill>
               </a:rPr>
               <a:t>行動可控</a:t>
             </a:r>
-            <a:endParaRPr lang="en-US" sz="1600" dirty="0"/>
+            <a:endParaRPr lang="en-US" sz="1500" dirty="0"/>
           </a:p>
         </p:txBody>
       </p:sp>
@@ -1938,8 +1938,8 @@
         </p:nvSpPr>
         <p:spPr>
           <a:xfrm>
-            <a:off x="3649142" y="5321808"/>
-            <a:ext cx="2131238" cy="685800"/>
+            <a:off x="3649142" y="4736592"/>
+            <a:ext cx="2131238" cy="457200"/>
           </a:xfrm>
           <a:prstGeom prst="rect">
             <a:avLst/>
@@ -1955,14 +1955,14 @@
               <a:buNone/>
             </a:pPr>
             <a:r>
-              <a:rPr lang="en-US" sz="1250" dirty="0">
+              <a:rPr lang="en-US" sz="1200" dirty="0">
                 <a:solidFill>
                   <a:schemeClr val="tx1"/>
                 </a:solidFill>
               </a:rPr>
               <a:t>只從列舉出的合法動作中挑選，不會產生不存在的操作</a:t>
             </a:r>
-            <a:endParaRPr lang="en-US" sz="1250" dirty="0"/>
+            <a:endParaRPr lang="en-US" sz="1200" dirty="0"/>
           </a:p>
         </p:txBody>
       </p:sp>
@@ -1974,12 +1974,12 @@
         </p:nvSpPr>
         <p:spPr>
           <a:xfrm>
-            <a:off x="6210148" y="4663440"/>
-            <a:ext cx="2533574" cy="1325880"/>
+            <a:off x="6210148" y="4224528"/>
+            <a:ext cx="2533574" cy="1024128"/>
           </a:xfrm>
           <a:prstGeom prst="roundRect">
             <a:avLst>
-              <a:gd name="adj" fmla="val 5517"/>
+              <a:gd name="adj" fmla="val 7143"/>
             </a:avLst>
           </a:prstGeom>
           <a:solidFill>
@@ -2001,7 +2001,7 @@
         </p:nvSpPr>
         <p:spPr>
           <a:xfrm>
-            <a:off x="6411316" y="4882896"/>
+            <a:off x="6411316" y="4352544"/>
             <a:ext cx="310896" cy="310896"/>
           </a:xfrm>
           <a:prstGeom prst="ellipse">
@@ -2026,7 +2026,7 @@
         </p:nvSpPr>
         <p:spPr>
           <a:xfrm>
-            <a:off x="6411316" y="4882896"/>
+            <a:off x="6411316" y="4352544"/>
             <a:ext cx="310896" cy="310896"/>
           </a:xfrm>
           <a:prstGeom prst="rect">
@@ -2062,8 +2062,8 @@
         </p:nvSpPr>
         <p:spPr>
           <a:xfrm>
-            <a:off x="6831940" y="4864608"/>
-            <a:ext cx="1756334" cy="365760"/>
+            <a:off x="6831940" y="4334256"/>
+            <a:ext cx="1756334" cy="347472"/>
           </a:xfrm>
           <a:prstGeom prst="rect">
             <a:avLst/>
@@ -2079,14 +2079,14 @@
               <a:buNone/>
             </a:pPr>
             <a:r>
-              <a:rPr lang="en-US" sz="1600" b="1" dirty="0">
+              <a:rPr lang="en-US" sz="1500" b="1" dirty="0">
                 <a:solidFill>
                   <a:schemeClr val="tx1"/>
                 </a:solidFill>
               </a:rPr>
               <a:t>有信心分數</a:t>
             </a:r>
-            <a:endParaRPr lang="en-US" sz="1600" dirty="0"/>
+            <a:endParaRPr lang="en-US" sz="1500" dirty="0"/>
           </a:p>
         </p:txBody>
       </p:sp>
@@ -2098,8 +2098,8 @@
         </p:nvSpPr>
         <p:spPr>
           <a:xfrm>
-            <a:off x="6411316" y="5321808"/>
-            <a:ext cx="2131238" cy="685800"/>
+            <a:off x="6411316" y="4736592"/>
+            <a:ext cx="2131238" cy="457200"/>
           </a:xfrm>
           <a:prstGeom prst="rect">
             <a:avLst/>
@@ -2115,14 +2115,14 @@
               <a:buNone/>
             </a:pPr>
             <a:r>
-              <a:rPr lang="en-US" sz="1250" dirty="0">
+              <a:rPr lang="en-US" sz="1200" dirty="0">
                 <a:solidFill>
                   <a:schemeClr val="tx1"/>
                 </a:solidFill>
               </a:rPr>
               <a:t>每一步附成功機率，可設門檻，低信心時轉給人工</a:t>
             </a:r>
-            <a:endParaRPr lang="en-US" sz="1250" dirty="0"/>
+            <a:endParaRPr lang="en-US" sz="1200" dirty="0"/>
           </a:p>
         </p:txBody>
       </p:sp>
@@ -2134,12 +2134,12 @@
         </p:nvSpPr>
         <p:spPr>
           <a:xfrm>
-            <a:off x="8972321" y="4663440"/>
-            <a:ext cx="2533574" cy="1325880"/>
+            <a:off x="8972321" y="4224528"/>
+            <a:ext cx="2533574" cy="1024128"/>
           </a:xfrm>
           <a:prstGeom prst="roundRect">
             <a:avLst>
-              <a:gd name="adj" fmla="val 5517"/>
+              <a:gd name="adj" fmla="val 7143"/>
             </a:avLst>
           </a:prstGeom>
           <a:solidFill>
@@ -2161,7 +2161,7 @@
         </p:nvSpPr>
         <p:spPr>
           <a:xfrm>
-            <a:off x="9173489" y="4882896"/>
+            <a:off x="9173489" y="4352544"/>
             <a:ext cx="310896" cy="310896"/>
           </a:xfrm>
           <a:prstGeom prst="ellipse">
@@ -2186,7 +2186,7 @@
         </p:nvSpPr>
         <p:spPr>
           <a:xfrm>
-            <a:off x="9173489" y="4882896"/>
+            <a:off x="9173489" y="4352544"/>
             <a:ext cx="310896" cy="310896"/>
           </a:xfrm>
           <a:prstGeom prst="rect">
@@ -2222,8 +2222,8 @@
         </p:nvSpPr>
         <p:spPr>
           <a:xfrm>
-            <a:off x="9594113" y="4864608"/>
-            <a:ext cx="1756334" cy="365760"/>
+            <a:off x="9594113" y="4334256"/>
+            <a:ext cx="1756334" cy="347472"/>
           </a:xfrm>
           <a:prstGeom prst="rect">
             <a:avLst/>
@@ -2239,14 +2239,14 @@
               <a:buNone/>
             </a:pPr>
             <a:r>
-              <a:rPr lang="en-US" sz="1600" b="1" dirty="0">
+              <a:rPr lang="en-US" sz="1500" b="1" dirty="0">
                 <a:solidFill>
                   <a:schemeClr val="tx1"/>
                 </a:solidFill>
               </a:rPr>
               <a:t>會自我進步</a:t>
             </a:r>
-            <a:endParaRPr lang="en-US" sz="1600" dirty="0"/>
+            <a:endParaRPr lang="en-US" sz="1500" dirty="0"/>
           </a:p>
         </p:txBody>
       </p:sp>
@@ -2258,8 +2258,8 @@
         </p:nvSpPr>
         <p:spPr>
           <a:xfrm>
-            <a:off x="9173489" y="5321808"/>
-            <a:ext cx="2131238" cy="685800"/>
+            <a:off x="9173489" y="4736592"/>
+            <a:ext cx="2131238" cy="457200"/>
           </a:xfrm>
           <a:prstGeom prst="rect">
             <a:avLst/>
@@ -2275,27 +2275,27 @@
               <a:buNone/>
             </a:pPr>
             <a:r>
-              <a:rPr lang="en-US" sz="1250" dirty="0">
+              <a:rPr lang="en-US" sz="1200" dirty="0">
                 <a:solidFill>
                   <a:schemeClr val="tx1"/>
                 </a:solidFill>
               </a:rPr>
               <a:t>在模擬環境自己練習：成功率 59% → 89%（相較只學示範）</a:t>
             </a:r>
-            <a:endParaRPr lang="en-US" sz="1250" dirty="0"/>
-          </a:p>
-        </p:txBody>
-      </p:sp>
-      <p:sp>
-        <p:nvSpPr>
-          <p:cNvPr id="41" name="source"/>
+            <a:endParaRPr lang="en-US" sz="1200" dirty="0"/>
+          </a:p>
+        </p:txBody>
+      </p:sp>
+      <p:sp>
+        <p:nvSpPr>
+          <p:cNvPr id="41" name="conclusions label"/>
           <p:cNvSpPr txBox="1"/>
           <p:nvPr/>
         </p:nvSpPr>
         <p:spPr>
           <a:xfrm>
-            <a:off x="685800" y="6217920"/>
-            <a:ext cx="10820095" cy="274320"/>
+            <a:off x="685800" y="5312664"/>
+            <a:ext cx="3657600" cy="274320"/>
           </a:xfrm>
           <a:prstGeom prst="rect">
             <a:avLst/>
@@ -2311,14 +2311,291 @@
               <a:buNone/>
             </a:pPr>
             <a:r>
-              <a:rPr lang="en-US" sz="1050" dirty="0">
+              <a:rPr lang="en-US" sz="1300" b="1" dirty="0">
                 <a:solidFill>
                   <a:schemeClr val="tx2"/>
                 </a:solidFill>
               </a:rPr>
-              <a:t>數據：TextWorld 文字冒險遊戲最難關卡 L3-goal（8 個房間、任務最少 8 步），100 場測試遊戲；兩邊每步都模擬 16 次。</a:t>
-            </a:r>
-            <a:endParaRPr lang="en-US" sz="1050" dirty="0"/>
+              <a:t>結論</a:t>
+            </a:r>
+            <a:endParaRPr lang="en-US" sz="1300" dirty="0"/>
+          </a:p>
+        </p:txBody>
+      </p:sp>
+      <p:sp>
+        <p:nvSpPr>
+          <p:cNvPr id="42" name="conclusions band"/>
+          <p:cNvSpPr/>
+          <p:nvPr/>
+        </p:nvSpPr>
+        <p:spPr>
+          <a:xfrm>
+            <a:off x="685800" y="5596128"/>
+            <a:ext cx="10820095" cy="777240"/>
+          </a:xfrm>
+          <a:prstGeom prst="roundRect">
+            <a:avLst>
+              <a:gd name="adj" fmla="val 9412"/>
+            </a:avLst>
+          </a:prstGeom>
+          <a:solidFill>
+            <a:srgbClr val="0F766E"/>
+          </a:solidFill>
+          <a:ln w="6350">
+            <a:solidFill>
+              <a:srgbClr val="0F766E"/>
+            </a:solidFill>
+            <a:prstDash val="solid"/>
+          </a:ln>
+        </p:spPr>
+      </p:sp>
+      <p:sp>
+        <p:nvSpPr>
+          <p:cNvPr id="43" name="conclusion 1"/>
+          <p:cNvSpPr txBox="1"/>
+          <p:nvPr/>
+        </p:nvSpPr>
+        <p:spPr>
+          <a:xfrm>
+            <a:off x="914400" y="5596128"/>
+            <a:ext cx="3240938" cy="777240"/>
+          </a:xfrm>
+          <a:prstGeom prst="rect">
+            <a:avLst/>
+          </a:prstGeom>
+          <a:noFill/>
+          <a:ln/>
+        </p:spPr>
+        <p:txBody>
+          <a:bodyPr wrap="square" lIns="0" tIns="0" rIns="0" bIns="0" rtlCol="0" anchor="ctr"/>
+          <a:lstStyle/>
+          <a:p>
+            <a:pPr indent="0" marL="0">
+              <a:spcAft>
+                <a:spcPts val="300"/>
+              </a:spcAft>
+              <a:buNone/>
+            </a:pPr>
+            <a:r>
+              <a:rPr lang="en-US" sz="1500" b="1" dirty="0">
+                <a:solidFill>
+                  <a:schemeClr val="bg1"/>
+                </a:solidFill>
+              </a:rPr>
+              <a:t>Laya + MCTS 顯著優於 MCTS</a:t>
+            </a:r>
+            <a:endParaRPr lang="en-US" sz="1400" dirty="0"/>
+          </a:p>
+          <a:p>
+            <a:pPr indent="0" marL="0">
+              <a:spcAft>
+                <a:spcPts val="300"/>
+              </a:spcAft>
+              <a:buNone/>
+            </a:pPr>
+            <a:r>
+              <a:rPr lang="en-US" sz="1200" dirty="0">
+                <a:solidFill>
+                  <a:schemeClr val="bg1"/>
+                </a:solidFill>
+              </a:rPr>
+              <a:t>最難關卡成功率 13% → 89%</a:t>
+            </a:r>
+            <a:endParaRPr lang="en-US" sz="1400" dirty="0"/>
+          </a:p>
+        </p:txBody>
+      </p:sp>
+      <p:sp>
+        <p:nvSpPr>
+          <p:cNvPr id="44" name="conclusion divider"/>
+          <p:cNvSpPr/>
+          <p:nvPr/>
+        </p:nvSpPr>
+        <p:spPr>
+          <a:xfrm>
+            <a:off x="4292498" y="5742432"/>
+            <a:ext cx="0" cy="484632"/>
+          </a:xfrm>
+          <a:prstGeom prst="line">
+            <a:avLst/>
+          </a:prstGeom>
+          <a:noFill/>
+          <a:ln w="9525">
+            <a:solidFill>
+              <a:srgbClr val="99C9C4"/>
+            </a:solidFill>
+            <a:prstDash val="solid"/>
+          </a:ln>
+        </p:spPr>
+      </p:sp>
+      <p:sp>
+        <p:nvSpPr>
+          <p:cNvPr id="45" name="conclusion 2"/>
+          <p:cNvSpPr txBox="1"/>
+          <p:nvPr/>
+        </p:nvSpPr>
+        <p:spPr>
+          <a:xfrm>
+            <a:off x="4521098" y="5596128"/>
+            <a:ext cx="3240938" cy="777240"/>
+          </a:xfrm>
+          <a:prstGeom prst="rect">
+            <a:avLst/>
+          </a:prstGeom>
+          <a:noFill/>
+          <a:ln/>
+        </p:spPr>
+        <p:txBody>
+          <a:bodyPr wrap="square" lIns="0" tIns="0" rIns="0" bIns="0" rtlCol="0" anchor="ctr"/>
+          <a:lstStyle/>
+          <a:p>
+            <a:pPr indent="0" marL="0">
+              <a:spcAft>
+                <a:spcPts val="300"/>
+              </a:spcAft>
+              <a:buNone/>
+            </a:pPr>
+            <a:r>
+              <a:rPr lang="en-US" sz="1500" b="1" dirty="0">
+                <a:solidFill>
+                  <a:schemeClr val="bg1"/>
+                </a:solidFill>
+              </a:rPr>
+              <a:t>Laya 必須先微調（fine-tune）</a:t>
+            </a:r>
+            <a:endParaRPr lang="en-US" sz="1400" dirty="0"/>
+          </a:p>
+          <a:p>
+            <a:pPr indent="0" marL="0">
+              <a:spcAft>
+                <a:spcPts val="300"/>
+              </a:spcAft>
+              <a:buNone/>
+            </a:pPr>
+            <a:r>
+              <a:rPr lang="en-US" sz="1200" dirty="0">
+                <a:solidFill>
+                  <a:schemeClr val="bg1"/>
+                </a:solidFill>
+              </a:rPr>
+              <a:t>未微調時反而比 MCTS 差：7% 對 13%</a:t>
+            </a:r>
+            <a:endParaRPr lang="en-US" sz="1400" dirty="0"/>
+          </a:p>
+        </p:txBody>
+      </p:sp>
+      <p:sp>
+        <p:nvSpPr>
+          <p:cNvPr id="46" name="conclusion divider"/>
+          <p:cNvSpPr/>
+          <p:nvPr/>
+        </p:nvSpPr>
+        <p:spPr>
+          <a:xfrm>
+            <a:off x="7899197" y="5742432"/>
+            <a:ext cx="0" cy="484632"/>
+          </a:xfrm>
+          <a:prstGeom prst="line">
+            <a:avLst/>
+          </a:prstGeom>
+          <a:noFill/>
+          <a:ln w="9525">
+            <a:solidFill>
+              <a:srgbClr val="99C9C4"/>
+            </a:solidFill>
+            <a:prstDash val="solid"/>
+          </a:ln>
+        </p:spPr>
+      </p:sp>
+      <p:sp>
+        <p:nvSpPr>
+          <p:cNvPr id="47" name="conclusion 3"/>
+          <p:cNvSpPr txBox="1"/>
+          <p:nvPr/>
+        </p:nvSpPr>
+        <p:spPr>
+          <a:xfrm>
+            <a:off x="8127797" y="5596128"/>
+            <a:ext cx="3240938" cy="777240"/>
+          </a:xfrm>
+          <a:prstGeom prst="rect">
+            <a:avLst/>
+          </a:prstGeom>
+          <a:noFill/>
+          <a:ln/>
+        </p:spPr>
+        <p:txBody>
+          <a:bodyPr wrap="square" lIns="0" tIns="0" rIns="0" bIns="0" rtlCol="0" anchor="ctr"/>
+          <a:lstStyle/>
+          <a:p>
+            <a:pPr indent="0" marL="0">
+              <a:spcAft>
+                <a:spcPts val="300"/>
+              </a:spcAft>
+              <a:buNone/>
+            </a:pPr>
+            <a:r>
+              <a:rPr lang="en-US" sz="1500" b="1" dirty="0">
+                <a:solidFill>
+                  <a:schemeClr val="bg1"/>
+                </a:solidFill>
+              </a:rPr>
+              <a:t>需要快速、低成本的模擬環境</a:t>
+            </a:r>
+            <a:endParaRPr lang="en-US" sz="1400" dirty="0"/>
+          </a:p>
+          <a:p>
+            <a:pPr indent="0" marL="0">
+              <a:spcAft>
+                <a:spcPts val="300"/>
+              </a:spcAft>
+              <a:buNone/>
+            </a:pPr>
+            <a:r>
+              <a:rPr lang="en-US" sz="1200" dirty="0">
+                <a:solidFill>
+                  <a:schemeClr val="bg1"/>
+                </a:solidFill>
+              </a:rPr>
+              <a:t>每步要試走 16 次；近八成時間花在模擬遊戲</a:t>
+            </a:r>
+            <a:endParaRPr lang="en-US" sz="1400" dirty="0"/>
+          </a:p>
+        </p:txBody>
+      </p:sp>
+      <p:sp>
+        <p:nvSpPr>
+          <p:cNvPr id="48" name="source"/>
+          <p:cNvSpPr txBox="1"/>
+          <p:nvPr/>
+        </p:nvSpPr>
+        <p:spPr>
+          <a:xfrm>
+            <a:off x="685800" y="6473952"/>
+            <a:ext cx="10820095" cy="228600"/>
+          </a:xfrm>
+          <a:prstGeom prst="rect">
+            <a:avLst/>
+          </a:prstGeom>
+          <a:noFill/>
+          <a:ln/>
+        </p:spPr>
+        <p:txBody>
+          <a:bodyPr wrap="square" lIns="0" tIns="0" rIns="0" bIns="0" rtlCol="0" anchor="t"/>
+          <a:lstStyle/>
+          <a:p>
+            <a:pPr indent="0" marL="0">
+              <a:buNone/>
+            </a:pPr>
+            <a:r>
+              <a:rPr lang="en-US" sz="1000" dirty="0">
+                <a:solidFill>
+                  <a:schemeClr val="tx2"/>
+                </a:solidFill>
+              </a:rPr>
+              <a:t>數據：TextWorld 文字冒險遊戲最難關卡 L3-goal（8 個房間、任務最少 8 步），100 場測試遊戲，兩邊每步都模擬 16 次；時間占比來自 L2-goal 的 GPU 速度測試。</a:t>
+            </a:r>
+            <a:endParaRPr lang="en-US" sz="1000" dirty="0"/>
           </a:p>
         </p:txBody>
       </p:sp>

</xml_diff>